<commit_message>
deck: carry the two-levers finding onto slides 7 and 8
Slide 7 was showing precompute taking the paid tier to +39% without the
section 8d consequence: at frontier inference the total AI line still runs
-$876k, because paid margin funds ~18k free users against 60k assumed, and
a monthly free digest rather than weekly is what reaches break-even.
Recommendation 2 on slide 8 rewritten to match. Slide 6 cards tightened to
remove dead space under the text.
</commit_message>
<xml_diff>
--- a/jade-audit-deck.pptx
+++ b/jade-audit-deck.pptx
@@ -5586,11 +5586,11 @@
         <p:spPr>
           <a:xfrm>
             <a:off x="548640" y="1920240"/>
-            <a:ext cx="5394960" cy="1920240"/>
+            <a:ext cx="5394960" cy="1600200"/>
           </a:xfrm>
           <a:prstGeom prst="roundRect">
             <a:avLst>
-              <a:gd name="adj" fmla="val 3810"/>
+              <a:gd name="adj" fmla="val 4571"/>
             </a:avLst>
           </a:prstGeom>
           <a:solidFill>
@@ -5612,8 +5612,8 @@
         </p:nvSpPr>
         <p:spPr>
           <a:xfrm>
-            <a:off x="777240" y="2057400"/>
-            <a:ext cx="4937760" cy="1645920"/>
+            <a:off x="777240" y="2029968"/>
+            <a:ext cx="4937760" cy="1371600"/>
           </a:xfrm>
           <a:prstGeom prst="rect">
             <a:avLst/>
@@ -5708,11 +5708,11 @@
         <p:spPr>
           <a:xfrm>
             <a:off x="6263640" y="1920240"/>
-            <a:ext cx="5394960" cy="1920240"/>
+            <a:ext cx="5394960" cy="1600200"/>
           </a:xfrm>
           <a:prstGeom prst="roundRect">
             <a:avLst>
-              <a:gd name="adj" fmla="val 3810"/>
+              <a:gd name="adj" fmla="val 4571"/>
             </a:avLst>
           </a:prstGeom>
           <a:solidFill>
@@ -5734,8 +5734,8 @@
         </p:nvSpPr>
         <p:spPr>
           <a:xfrm>
-            <a:off x="6492240" y="2057400"/>
-            <a:ext cx="4937760" cy="1645920"/>
+            <a:off x="6492240" y="2029968"/>
+            <a:ext cx="4937760" cy="1371600"/>
           </a:xfrm>
           <a:prstGeom prst="rect">
             <a:avLst/>
@@ -5790,8 +5790,8 @@
         </p:nvSpPr>
         <p:spPr>
           <a:xfrm>
-            <a:off x="548640" y="4160520"/>
-            <a:ext cx="11064240" cy="2103120"/>
+            <a:off x="548640" y="3840480"/>
+            <a:ext cx="11064240" cy="2377440"/>
           </a:xfrm>
           <a:prstGeom prst="rect">
             <a:avLst/>
@@ -6040,8 +6040,8 @@
         </p:nvSpPr>
         <p:spPr>
           <a:xfrm>
-            <a:off x="7315200" y="1737360"/>
-            <a:ext cx="4297680" cy="4023360"/>
+            <a:off x="7269480" y="1645920"/>
+            <a:ext cx="4389120" cy="4480560"/>
           </a:xfrm>
           <a:prstGeom prst="rect">
             <a:avLst/>
@@ -6057,7 +6057,7 @@
               <a:buNone/>
             </a:pPr>
             <a:r>
-              <a:rPr lang="en-US" sz="1300" b="1" dirty="0">
+              <a:rPr lang="en-US" sz="1250" b="1" dirty="0">
                 <a:solidFill>
                   <a:srgbClr val="1A1A2E"/>
                 </a:solidFill>
@@ -6065,14 +6065,14 @@
                 <a:ea typeface="Calibri" pitchFamily="34" charset="-122"/>
                 <a:cs typeface="Calibri" pitchFamily="34" charset="-120"/>
               </a:rPr>
-              <a:t>Heavy user, 60 q/mo, per year:
+              <a:t>Heavy user, 60 q/mo, per year
 </a:t>
             </a:r>
             <a:pPr indent="0" marL="0">
               <a:buNone/>
             </a:pPr>
             <a:r>
-              <a:rPr lang="en-US" sz="1300" dirty="0">
+              <a:rPr lang="en-US" sz="1250" dirty="0">
                 <a:solidFill>
                   <a:srgbClr val="1A1A2E"/>
                 </a:solidFill>
@@ -6080,15 +6080,14 @@
                 <a:ea typeface="Calibri" pitchFamily="34" charset="-122"/>
                 <a:cs typeface="Calibri" pitchFamily="34" charset="-120"/>
               </a:rPr>
-              <a:t>$252 to serve on demand
-$29 under precompute
+              <a:t>$252 on demand  -&gt;  $29 precompute
 </a:t>
             </a:r>
             <a:pPr indent="0" marL="0">
               <a:buNone/>
             </a:pPr>
             <a:r>
-              <a:rPr lang="en-US" sz="1300" b="1" dirty="0">
+              <a:rPr lang="en-US" sz="1250" b="1" dirty="0">
                 <a:solidFill>
                   <a:srgbClr val="1A1A2E"/>
                 </a:solidFill>
@@ -6096,14 +6095,14 @@
                 <a:ea typeface="Calibri" pitchFamily="34" charset="-122"/>
                 <a:cs typeface="Calibri" pitchFamily="34" charset="-120"/>
               </a:rPr>
-              <a:t>Paid gross margin:
+              <a:t>Paid gross margin
 </a:t>
             </a:r>
             <a:pPr indent="0" marL="0">
               <a:buNone/>
             </a:pPr>
             <a:r>
-              <a:rPr lang="en-US" sz="1300" dirty="0">
+              <a:rPr lang="en-US" sz="1250" dirty="0">
                 <a:solidFill>
                   <a:srgbClr val="1A1A2E"/>
                 </a:solidFill>
@@ -6113,24 +6112,95 @@
               </a:rPr>
               <a:t>-426% today (frontier)
 +39% precompute at 60 q/mo
-+56% at regular usage
 </a:t>
             </a:r>
             <a:pPr indent="0" marL="0">
               <a:buNone/>
             </a:pPr>
             <a:r>
-              <a:rPr lang="en-US" sz="1250" i="1" dirty="0">
-                <a:solidFill>
-                  <a:srgbClr val="5A5A6E"/>
+              <a:rPr lang="en-US" sz="1250" b="1" dirty="0">
+                <a:solidFill>
+                  <a:srgbClr val="C0392B"/>
                 </a:solidFill>
                 <a:latin typeface="Calibri" pitchFamily="34" charset="0"/>
                 <a:ea typeface="Calibri" pitchFamily="34" charset="-122"/>
                 <a:cs typeface="Calibri" pitchFamily="34" charset="-120"/>
               </a:rPr>
-              <a:t>Metering becomes unnecessary rather than merely undesirable.</a:t>
-            </a:r>
-            <a:endParaRPr lang="en-US" sz="1300" dirty="0"/>
+              <a:t>But one lever is not enough.
+</a:t>
+            </a:r>
+            <a:pPr indent="0" marL="0">
+              <a:buNone/>
+            </a:pPr>
+            <a:r>
+              <a:rPr lang="en-US" sz="1200" dirty="0">
+                <a:solidFill>
+                  <a:srgbClr val="1A1A2E"/>
+                </a:solidFill>
+                <a:latin typeface="Calibri" pitchFamily="34" charset="0"/>
+                <a:ea typeface="Calibri" pitchFamily="34" charset="-122"/>
+                <a:cs typeface="Calibri" pitchFamily="34" charset="-120"/>
+              </a:rPr>
+              <a:t>Precompute fixes the paid tier in every scenario. The total AI line still runs </a:t>
+            </a:r>
+            <a:pPr indent="0" marL="0">
+              <a:buNone/>
+            </a:pPr>
+            <a:r>
+              <a:rPr lang="en-US" sz="1200" b="1" dirty="0">
+                <a:solidFill>
+                  <a:srgbClr val="1A1A2E"/>
+                </a:solidFill>
+                <a:latin typeface="Calibri" pitchFamily="34" charset="0"/>
+                <a:ea typeface="Calibri" pitchFamily="34" charset="-122"/>
+                <a:cs typeface="Calibri" pitchFamily="34" charset="-120"/>
+              </a:rPr>
+              <a:t>-$876k</a:t>
+            </a:r>
+            <a:pPr indent="0" marL="0">
+              <a:buNone/>
+            </a:pPr>
+            <a:r>
+              <a:rPr lang="en-US" sz="1200" dirty="0">
+                <a:solidFill>
+                  <a:srgbClr val="1A1A2E"/>
+                </a:solidFill>
+                <a:latin typeface="Calibri" pitchFamily="34" charset="0"/>
+                <a:ea typeface="Calibri" pitchFamily="34" charset="-122"/>
+                <a:cs typeface="Calibri" pitchFamily="34" charset="-120"/>
+              </a:rPr>
+              <a:t> at frontier cost, because paid margin funds ~18k free users against 60k assumed.
+</a:t>
+            </a:r>
+            <a:pPr indent="0" marL="0">
+              <a:buNone/>
+            </a:pPr>
+            <a:r>
+              <a:rPr lang="en-US" sz="1200" dirty="0">
+                <a:solidFill>
+                  <a:srgbClr val="1A1A2E"/>
+                </a:solidFill>
+                <a:latin typeface="Calibri" pitchFamily="34" charset="0"/>
+                <a:ea typeface="Calibri" pitchFamily="34" charset="-122"/>
+                <a:cs typeface="Calibri" pitchFamily="34" charset="-120"/>
+              </a:rPr>
+              <a:t>A monthly free digest instead of weekly reaches break-even on frontier inference alone. </a:t>
+            </a:r>
+            <a:pPr indent="0" marL="0">
+              <a:buNone/>
+            </a:pPr>
+            <a:r>
+              <a:rPr lang="en-US" sz="1200" b="1" dirty="0">
+                <a:solidFill>
+                  <a:srgbClr val="1A1A2E"/>
+                </a:solidFill>
+                <a:latin typeface="Calibri" pitchFamily="34" charset="0"/>
+                <a:ea typeface="Calibri" pitchFamily="34" charset="-122"/>
+                <a:cs typeface="Calibri" pitchFamily="34" charset="-120"/>
+              </a:rPr>
+              <a:t>Two levers, jointly necessary.</a:t>
+            </a:r>
+            <a:endParaRPr lang="en-US" sz="1250" dirty="0"/>
           </a:p>
         </p:txBody>
       </p:sp>
@@ -6263,7 +6333,7 @@
                 <a:ea typeface="Calibri" pitchFamily="34" charset="-122"/>
                 <a:cs typeface="Calibri" pitchFamily="34" charset="-120"/>
               </a:rPr>
-              <a:t>Keep the paid tier; stop metering the free one. With cost fixed per user, $3.99 clears an estimated ~55% gross margin at regular usage. A lighter free digest protects wear compliance - the binding constraint on whether personalised health AI works at all.</a:t>
+              <a:t>Keep the paid tier; set the free tier's cadence deliberately. With cost fixed per user the paid tier clears a healthy margin, but the free tier is the second lever, not a footnote: a monthly free digest instead of a weekly one is the difference between -$876k and break-even at frontier inference. It still protects wear compliance, which is the binding constraint on whether personalised health AI works at all.</a:t>
             </a:r>
             <a:endParaRPr lang="en-US" sz="1450" dirty="0"/>
           </a:p>

</xml_diff>